<commit_message>
Complète la documentation, corrige les modèles Merise et unifie les dépendances
- Démarrage rapide (téléchargement, .env, Docker) en tête du README, qui est réorganisé
- .env.example : un commentaire explicatif par variable
- Nouveaux documents : index docs, cartographie source -> cible, exploitation, licences/RGPD, limites connues
- docs/architecture et docs/quality regroupés chacun en un seul README
- MCD avec identifiants, MLD corrigé (cardinalités, notation relationnelle), DBML complet (11 tables)
- Correction du domaine ROME « A » (parseur, test unitaire, règle de nettoyage R04)
- Un seul requirements.txt pour toutes les images Docker

Co-authored-by: Copilot <223556219+Copilot@users.noreply.github.com>
</commit_message>
<xml_diff>
--- a/docs/presentation/project-presentation.pptx
+++ b/docs/presentation/project-presentation.pptx
@@ -175,11 +175,11 @@
         </c:ser>
         <c:gapWidth val="60"/>
         <c:overlap val="0"/>
-        <c:axId val="29845970"/>
-        <c:axId val="7841076"/>
+        <c:axId val="91696518"/>
+        <c:axId val="38022805"/>
       </c:barChart>
       <c:catAx>
-        <c:axId val="29845970"/>
+        <c:axId val="91696518"/>
         <c:scaling>
           <c:orientation val="minMax"/>
         </c:scaling>
@@ -212,7 +212,7 @@
             </a:pPr>
           </a:p>
         </c:txPr>
-        <c:crossAx val="7841076"/>
+        <c:crossAx val="38022805"/>
         <c:crosses val="autoZero"/>
         <c:auto val="1"/>
         <c:lblAlgn val="ctr"/>
@@ -220,7 +220,7 @@
         <c:noMultiLvlLbl val="0"/>
       </c:catAx>
       <c:valAx>
-        <c:axId val="7841076"/>
+        <c:axId val="38022805"/>
         <c:scaling>
           <c:orientation val="minMax"/>
         </c:scaling>
@@ -253,7 +253,7 @@
             </a:pPr>
           </a:p>
         </c:txPr>
-        <c:crossAx val="29845970"/>
+        <c:crossAx val="91696518"/>
         <c:crossBetween val="between"/>
       </c:valAx>
       <c:spPr>
@@ -846,7 +846,7 @@
             <a:pPr indent="0" algn="r">
               <a:buNone/>
             </a:pPr>
-            <a:fld id="{689E7182-EDFF-4A76-9C7D-2298A2006F55}" type="slidenum">
+            <a:fld id="{2782F6B8-880A-40ED-857F-B46970C89FEB}" type="slidenum">
               <a:rPr lang="fr-FR" sz="1400" b="0" u="none" strike="noStrike">
                 <a:solidFill>
                   <a:srgbClr val="000000"/>
@@ -1020,7 +1020,7 @@
               </a:lnSpc>
               <a:buNone/>
             </a:pPr>
-            <a:fld id="{D4766E3C-0BDE-411A-8B77-789274A65132}" type="slidenum">
+            <a:fld id="{5618EE98-6D0A-4F6A-AFAB-06318F82DA10}" type="slidenum">
               <a:rPr lang="en-US" sz="1200" b="0" u="none" strike="noStrike">
                 <a:solidFill>
                   <a:srgbClr val="000000"/>
@@ -1193,7 +1193,7 @@
               </a:lnSpc>
               <a:buNone/>
             </a:pPr>
-            <a:fld id="{59EC7AF7-6F65-4ECC-A7C3-989293193ACC}" type="slidenum">
+            <a:fld id="{DD1EFF9C-C035-43E8-9430-4D6EC3AB9FF8}" type="slidenum">
               <a:rPr lang="en-US" sz="1200" b="0" u="none" strike="noStrike">
                 <a:solidFill>
                   <a:srgbClr val="000000"/>
@@ -1366,7 +1366,7 @@
               </a:lnSpc>
               <a:buNone/>
             </a:pPr>
-            <a:fld id="{10DF791A-F411-4BF4-BC10-49CEF7773D0E}" type="slidenum">
+            <a:fld id="{EA304CA6-F69D-4977-90CB-26847E0CFF09}" type="slidenum">
               <a:rPr lang="en-US" sz="1200" b="0" u="none" strike="noStrike">
                 <a:solidFill>
                   <a:srgbClr val="000000"/>
@@ -1539,7 +1539,7 @@
               </a:lnSpc>
               <a:buNone/>
             </a:pPr>
-            <a:fld id="{A41E2389-1A41-4DDF-A409-EA854B35FB97}" type="slidenum">
+            <a:fld id="{05827A39-29B8-4998-A3A3-7D1910A2E81E}" type="slidenum">
               <a:rPr lang="en-US" sz="1200" b="0" u="none" strike="noStrike">
                 <a:solidFill>
                   <a:srgbClr val="000000"/>
@@ -1712,7 +1712,7 @@
               </a:lnSpc>
               <a:buNone/>
             </a:pPr>
-            <a:fld id="{54BF95E2-B14A-4623-9B3C-8DCD5C665C23}" type="slidenum">
+            <a:fld id="{2C8EEF0C-A445-4105-8876-C8152023CD57}" type="slidenum">
               <a:rPr lang="en-US" sz="1200" b="0" u="none" strike="noStrike">
                 <a:solidFill>
                   <a:srgbClr val="000000"/>
@@ -1885,7 +1885,7 @@
               </a:lnSpc>
               <a:buNone/>
             </a:pPr>
-            <a:fld id="{2CF0AF2E-060E-4E3A-8C8E-9DE12AAA964A}" type="slidenum">
+            <a:fld id="{9F6B93AA-2C6B-40D3-82B3-3AA5CC13737C}" type="slidenum">
               <a:rPr lang="en-US" sz="1200" b="0" u="none" strike="noStrike">
                 <a:solidFill>
                   <a:srgbClr val="000000"/>
@@ -2058,7 +2058,7 @@
               </a:lnSpc>
               <a:buNone/>
             </a:pPr>
-            <a:fld id="{B2FA24B7-699E-44D4-9DC9-B8A7A9C0F65D}" type="slidenum">
+            <a:fld id="{3F5508CF-E277-4F8D-A03D-7D80C4CE63A4}" type="slidenum">
               <a:rPr lang="en-US" sz="1200" b="0" u="none" strike="noStrike">
                 <a:solidFill>
                   <a:srgbClr val="000000"/>
@@ -2231,7 +2231,7 @@
               </a:lnSpc>
               <a:buNone/>
             </a:pPr>
-            <a:fld id="{A388E570-1FCE-4D71-9DD0-FF13D251851B}" type="slidenum">
+            <a:fld id="{FF9CE0CD-FE3C-4D85-BABA-84085878A5B3}" type="slidenum">
               <a:rPr lang="en-US" sz="1200" b="0" u="none" strike="noStrike">
                 <a:solidFill>
                   <a:srgbClr val="000000"/>
@@ -2404,7 +2404,7 @@
               </a:lnSpc>
               <a:buNone/>
             </a:pPr>
-            <a:fld id="{1CC8BD70-B8B9-4088-9BCF-C92ECEE63591}" type="slidenum">
+            <a:fld id="{8286F76A-26DB-4423-8755-2638903A10FA}" type="slidenum">
               <a:rPr lang="en-US" sz="1200" b="0" u="none" strike="noStrike">
                 <a:solidFill>
                   <a:srgbClr val="000000"/>
@@ -2577,7 +2577,7 @@
               </a:lnSpc>
               <a:buNone/>
             </a:pPr>
-            <a:fld id="{15AD32BD-A7E0-4723-BFE9-6ADAB5C987C4}" type="slidenum">
+            <a:fld id="{996A90FD-E25A-4DA3-8865-15AF60B6F530}" type="slidenum">
               <a:rPr lang="en-US" sz="1200" b="0" u="none" strike="noStrike">
                 <a:solidFill>
                   <a:srgbClr val="000000"/>
@@ -2750,7 +2750,7 @@
               </a:lnSpc>
               <a:buNone/>
             </a:pPr>
-            <a:fld id="{18D9E311-CF35-4DD1-B317-64DCFE95F1EE}" type="slidenum">
+            <a:fld id="{1A52C31F-45EA-4B3B-B22C-2428BD36AD18}" type="slidenum">
               <a:rPr lang="en-US" sz="1200" b="0" u="none" strike="noStrike">
                 <a:solidFill>
                   <a:srgbClr val="000000"/>
@@ -2923,7 +2923,7 @@
               </a:lnSpc>
               <a:buNone/>
             </a:pPr>
-            <a:fld id="{2E71885E-9E6B-4C8D-9615-5B3C9305F19D}" type="slidenum">
+            <a:fld id="{47E2FC1E-2BF2-41AE-B0FE-5EC466F55E10}" type="slidenum">
               <a:rPr lang="en-US" sz="1200" b="0" u="none" strike="noStrike">
                 <a:solidFill>
                   <a:srgbClr val="000000"/>
@@ -3096,7 +3096,7 @@
               </a:lnSpc>
               <a:buNone/>
             </a:pPr>
-            <a:fld id="{F792B9E5-D235-47F2-A1EE-928DBE3F52D7}" type="slidenum">
+            <a:fld id="{AE5F5259-DF4A-4DC3-B9BB-E799CACDC32B}" type="slidenum">
               <a:rPr lang="en-US" sz="1200" b="0" u="none" strike="noStrike">
                 <a:solidFill>
                   <a:srgbClr val="000000"/>
@@ -3269,7 +3269,7 @@
               </a:lnSpc>
               <a:buNone/>
             </a:pPr>
-            <a:fld id="{7B09A4BA-BFC7-4903-8072-1F3219219451}" type="slidenum">
+            <a:fld id="{A0BE49E0-CFE4-47A5-9FCD-4573A5ECE27E}" type="slidenum">
               <a:rPr lang="en-US" sz="1200" b="0" u="none" strike="noStrike">
                 <a:solidFill>
                   <a:srgbClr val="000000"/>
@@ -3442,7 +3442,7 @@
               </a:lnSpc>
               <a:buNone/>
             </a:pPr>
-            <a:fld id="{64226D48-70EF-41ED-A525-306835CB1B4C}" type="slidenum">
+            <a:fld id="{D8369987-AF75-4570-AFF6-01DE72A2BEB1}" type="slidenum">
               <a:rPr lang="en-US" sz="1200" b="0" u="none" strike="noStrike">
                 <a:solidFill>
                   <a:srgbClr val="000000"/>
@@ -3615,7 +3615,7 @@
               </a:lnSpc>
               <a:buNone/>
             </a:pPr>
-            <a:fld id="{43D5E521-4341-42C8-8CA4-59D918C3D1BB}" type="slidenum">
+            <a:fld id="{DD5F4A17-B27D-4FC5-80D1-E44D99E2BF85}" type="slidenum">
               <a:rPr lang="en-US" sz="1200" b="0" u="none" strike="noStrike">
                 <a:solidFill>
                   <a:srgbClr val="000000"/>
@@ -3801,7 +3801,7 @@
                 <a:uFillTx/>
                 <a:latin typeface="Calibri"/>
               </a:rPr>
-              <a:t> </a:t>
+              <a:t>&lt;date/heure&gt;</a:t>
             </a:r>
             <a:endParaRPr lang="fr-FR" sz="1200" b="0" u="none" strike="noStrike">
               <a:solidFill>
@@ -3867,7 +3867,7 @@
                 <a:uFillTx/>
                 <a:latin typeface="Times New Roman"/>
               </a:rPr>
-              <a:t> </a:t>
+              <a:t>&lt;pied de page&gt;</a:t>
             </a:r>
             <a:endParaRPr lang="fr-FR" sz="1400" b="0" u="none" strike="noStrike">
               <a:solidFill>
@@ -3932,7 +3932,7 @@
               </a:lnSpc>
               <a:buNone/>
             </a:pPr>
-            <a:fld id="{A84DB9D4-A5B5-4CE7-9FB4-6C2506075AFE}" type="slidenum">
+            <a:fld id="{6C0D374B-0D34-493C-AEAD-F86E9AFE075E}" type="slidenum">
               <a:rPr lang="en-US" sz="1200" b="0" u="none" strike="noStrike">
                 <a:solidFill>
                   <a:schemeClr val="dk1">
@@ -3943,7 +3943,7 @@
                 <a:uFillTx/>
                 <a:latin typeface="Calibri"/>
               </a:rPr>
-              <a:t>1</a:t>
+              <a:t>&lt;numéro&gt;</a:t>
             </a:fld>
             <a:endParaRPr lang="fr-FR" sz="1200" b="0" u="none" strike="noStrike">
               <a:solidFill>
@@ -4644,7 +4644,7 @@
               </a:lnSpc>
               <a:buNone/>
             </a:pPr>
-            <a:fld id="{A979CC2F-4FB8-43CA-86AC-787E3F3DEFC9}" type="slidenum">
+            <a:fld id="{A17B2EAE-605F-401E-8192-D22539D28ACD}" type="slidenum">
               <a:rPr lang="en-US" sz="1200" b="0" u="none" strike="noStrike">
                 <a:solidFill>
                   <a:schemeClr val="dk1">
@@ -5103,7 +5103,7 @@
               </a:lnSpc>
               <a:buNone/>
             </a:pPr>
-            <a:fld id="{A6570513-98BF-47B5-9E46-48B830A437DE}" type="slidenum">
+            <a:fld id="{759CB45D-39D0-43F2-9980-1FB9D895F4AD}" type="slidenum">
               <a:rPr lang="en-US" sz="1200" b="0" u="none" strike="noStrike">
                 <a:solidFill>
                   <a:schemeClr val="dk1">
@@ -5600,7 +5600,7 @@
                 <a:uFillTx/>
                 <a:latin typeface="Calibri"/>
               </a:rPr>
-              <a:t> </a:t>
+              <a:t>&lt;date/heure&gt;</a:t>
             </a:r>
             <a:endParaRPr lang="fr-FR" sz="1200" b="0" u="none" strike="noStrike">
               <a:solidFill>
@@ -5666,7 +5666,7 @@
                 <a:uFillTx/>
                 <a:latin typeface="Times New Roman"/>
               </a:rPr>
-              <a:t> </a:t>
+              <a:t>&lt;pied de page&gt;</a:t>
             </a:r>
             <a:endParaRPr lang="fr-FR" sz="1400" b="0" u="none" strike="noStrike">
               <a:solidFill>
@@ -5731,7 +5731,7 @@
               </a:lnSpc>
               <a:buNone/>
             </a:pPr>
-            <a:fld id="{0130C414-DF2F-49F3-945E-DCE0452ABA82}" type="slidenum">
+            <a:fld id="{0B899F6F-8C0C-4B77-A924-870F615696B6}" type="slidenum">
               <a:rPr lang="en-US" sz="1200" b="0" u="none" strike="noStrike">
                 <a:solidFill>
                   <a:schemeClr val="dk1">
@@ -5742,7 +5742,7 @@
                 <a:uFillTx/>
                 <a:latin typeface="Calibri"/>
               </a:rPr>
-              <a:t>1</a:t>
+              <a:t>&lt;numéro&gt;</a:t>
             </a:fld>
             <a:endParaRPr lang="fr-FR" sz="1200" b="0" u="none" strike="noStrike">
               <a:solidFill>
@@ -6228,7 +6228,7 @@
                 <a:uFillTx/>
                 <a:latin typeface="Calibri"/>
               </a:rPr>
-              <a:t> </a:t>
+              <a:t>&lt;date/heure&gt;</a:t>
             </a:r>
             <a:endParaRPr lang="fr-FR" sz="1200" b="0" u="none" strike="noStrike">
               <a:solidFill>
@@ -6294,7 +6294,7 @@
                 <a:uFillTx/>
                 <a:latin typeface="Times New Roman"/>
               </a:rPr>
-              <a:t> </a:t>
+              <a:t>&lt;pied de page&gt;</a:t>
             </a:r>
             <a:endParaRPr lang="fr-FR" sz="1400" b="0" u="none" strike="noStrike">
               <a:solidFill>
@@ -6359,7 +6359,7 @@
               </a:lnSpc>
               <a:buNone/>
             </a:pPr>
-            <a:fld id="{75F456D1-669C-4142-B28B-5B02C21B327F}" type="slidenum">
+            <a:fld id="{7284ED76-4566-4B86-9C60-662939DE6C23}" type="slidenum">
               <a:rPr lang="en-US" sz="1200" b="0" u="none" strike="noStrike">
                 <a:solidFill>
                   <a:schemeClr val="dk1">
@@ -6370,7 +6370,7 @@
                 <a:uFillTx/>
                 <a:latin typeface="Calibri"/>
               </a:rPr>
-              <a:t>1</a:t>
+              <a:t>&lt;numéro&gt;</a:t>
             </a:fld>
             <a:endParaRPr lang="fr-FR" sz="1200" b="0" u="none" strike="noStrike">
               <a:solidFill>
@@ -6856,7 +6856,7 @@
                 <a:uFillTx/>
                 <a:latin typeface="Calibri"/>
               </a:rPr>
-              <a:t> </a:t>
+              <a:t>&lt;date/heure&gt;</a:t>
             </a:r>
             <a:endParaRPr lang="fr-FR" sz="1200" b="0" u="none" strike="noStrike">
               <a:solidFill>
@@ -6922,7 +6922,7 @@
                 <a:uFillTx/>
                 <a:latin typeface="Times New Roman"/>
               </a:rPr>
-              <a:t> </a:t>
+              <a:t>&lt;pied de page&gt;</a:t>
             </a:r>
             <a:endParaRPr lang="fr-FR" sz="1400" b="0" u="none" strike="noStrike">
               <a:solidFill>
@@ -6987,7 +6987,7 @@
               </a:lnSpc>
               <a:buNone/>
             </a:pPr>
-            <a:fld id="{CEFEEC41-6D17-4202-B019-BC3C2B3D4142}" type="slidenum">
+            <a:fld id="{8778C3C9-2660-4D24-9736-343EB0A87059}" type="slidenum">
               <a:rPr lang="en-US" sz="1200" b="0" u="none" strike="noStrike">
                 <a:solidFill>
                   <a:schemeClr val="dk1">
@@ -6998,7 +6998,7 @@
                 <a:uFillTx/>
                 <a:latin typeface="Calibri"/>
               </a:rPr>
-              <a:t>1</a:t>
+              <a:t>&lt;numéro&gt;</a:t>
             </a:fld>
             <a:endParaRPr lang="fr-FR" sz="1200" b="0" u="none" strike="noStrike">
               <a:solidFill>
@@ -7268,7 +7268,7 @@
                 <a:uFillTx/>
                 <a:latin typeface="Calibri"/>
               </a:rPr>
-              <a:t> </a:t>
+              <a:t>&lt;date/heure&gt;</a:t>
             </a:r>
             <a:endParaRPr lang="fr-FR" sz="1200" b="0" u="none" strike="noStrike">
               <a:solidFill>
@@ -7334,7 +7334,7 @@
                 <a:uFillTx/>
                 <a:latin typeface="Times New Roman"/>
               </a:rPr>
-              <a:t> </a:t>
+              <a:t>&lt;pied de page&gt;</a:t>
             </a:r>
             <a:endParaRPr lang="fr-FR" sz="1400" b="0" u="none" strike="noStrike">
               <a:solidFill>
@@ -7399,7 +7399,7 @@
               </a:lnSpc>
               <a:buNone/>
             </a:pPr>
-            <a:fld id="{2B633C16-DA6A-420C-8653-D818ADDD3109}" type="slidenum">
+            <a:fld id="{C86130F4-7279-4DBA-95C9-F758BC0DB09A}" type="slidenum">
               <a:rPr lang="en-US" sz="1200" b="0" u="none" strike="noStrike">
                 <a:solidFill>
                   <a:schemeClr val="dk1">
@@ -7410,7 +7410,7 @@
                 <a:uFillTx/>
                 <a:latin typeface="Calibri"/>
               </a:rPr>
-              <a:t>1</a:t>
+              <a:t>&lt;numéro&gt;</a:t>
             </a:fld>
             <a:endParaRPr lang="fr-FR" sz="1200" b="0" u="none" strike="noStrike">
               <a:solidFill>
@@ -8202,7 +8202,7 @@
                 <a:uFillTx/>
                 <a:latin typeface="Calibri"/>
               </a:rPr>
-              <a:t> </a:t>
+              <a:t>&lt;date/heure&gt;</a:t>
             </a:r>
             <a:endParaRPr lang="fr-FR" sz="1200" b="0" u="none" strike="noStrike">
               <a:solidFill>
@@ -8268,7 +8268,7 @@
                 <a:uFillTx/>
                 <a:latin typeface="Times New Roman"/>
               </a:rPr>
-              <a:t> </a:t>
+              <a:t>&lt;pied de page&gt;</a:t>
             </a:r>
             <a:endParaRPr lang="fr-FR" sz="1400" b="0" u="none" strike="noStrike">
               <a:solidFill>
@@ -8333,7 +8333,7 @@
               </a:lnSpc>
               <a:buNone/>
             </a:pPr>
-            <a:fld id="{6D4726FB-CD75-4A9B-9D4B-B5848B3E7EC1}" type="slidenum">
+            <a:fld id="{68E78CED-3E0A-461B-9AB3-BCB14CCD78A2}" type="slidenum">
               <a:rPr lang="en-US" sz="1200" b="0" u="none" strike="noStrike">
                 <a:solidFill>
                   <a:schemeClr val="dk1">
@@ -8344,7 +8344,7 @@
                 <a:uFillTx/>
                 <a:latin typeface="Calibri"/>
               </a:rPr>
-              <a:t>1</a:t>
+              <a:t>&lt;numéro&gt;</a:t>
             </a:fld>
             <a:endParaRPr lang="fr-FR" sz="1200" b="0" u="none" strike="noStrike">
               <a:solidFill>
@@ -9364,7 +9364,7 @@
                 <a:uFillTx/>
                 <a:latin typeface="Calibri"/>
               </a:rPr>
-              <a:t> </a:t>
+              <a:t>&lt;date/heure&gt;</a:t>
             </a:r>
             <a:endParaRPr lang="fr-FR" sz="1200" b="0" u="none" strike="noStrike">
               <a:solidFill>
@@ -9430,7 +9430,7 @@
                 <a:uFillTx/>
                 <a:latin typeface="Times New Roman"/>
               </a:rPr>
-              <a:t> </a:t>
+              <a:t>&lt;pied de page&gt;</a:t>
             </a:r>
             <a:endParaRPr lang="fr-FR" sz="1400" b="0" u="none" strike="noStrike">
               <a:solidFill>
@@ -9495,7 +9495,7 @@
               </a:lnSpc>
               <a:buNone/>
             </a:pPr>
-            <a:fld id="{11A1D90B-C533-44BB-AFCA-792809E05D28}" type="slidenum">
+            <a:fld id="{8C7F6FFE-F987-4A34-B1FF-2FBF0541F9D4}" type="slidenum">
               <a:rPr lang="en-US" sz="1200" b="0" u="none" strike="noStrike">
                 <a:solidFill>
                   <a:schemeClr val="dk1">
@@ -9506,7 +9506,7 @@
                 <a:uFillTx/>
                 <a:latin typeface="Calibri"/>
               </a:rPr>
-              <a:t>1</a:t>
+              <a:t>&lt;numéro&gt;</a:t>
             </a:fld>
             <a:endParaRPr lang="fr-FR" sz="1200" b="0" u="none" strike="noStrike">
               <a:solidFill>
@@ -9686,7 +9686,7 @@
                 <a:uFillTx/>
                 <a:latin typeface="Calibri"/>
               </a:rPr>
-              <a:t> </a:t>
+              <a:t>&lt;date/heure&gt;</a:t>
             </a:r>
             <a:endParaRPr lang="fr-FR" sz="1200" b="0" u="none" strike="noStrike">
               <a:solidFill>
@@ -9752,7 +9752,7 @@
                 <a:uFillTx/>
                 <a:latin typeface="Times New Roman"/>
               </a:rPr>
-              <a:t> </a:t>
+              <a:t>&lt;pied de page&gt;</a:t>
             </a:r>
             <a:endParaRPr lang="fr-FR" sz="1400" b="0" u="none" strike="noStrike">
               <a:solidFill>
@@ -9817,7 +9817,7 @@
               </a:lnSpc>
               <a:buNone/>
             </a:pPr>
-            <a:fld id="{A3E76AEA-4A94-41CD-8F81-74153468610E}" type="slidenum">
+            <a:fld id="{6FDFBDC0-2935-4E9E-89E9-30C965F508B9}" type="slidenum">
               <a:rPr lang="en-US" sz="1200" b="0" u="none" strike="noStrike">
                 <a:solidFill>
                   <a:schemeClr val="dk1">
@@ -9828,7 +9828,7 @@
                 <a:uFillTx/>
                 <a:latin typeface="Calibri"/>
               </a:rPr>
-              <a:t>1</a:t>
+              <a:t>&lt;numéro&gt;</a:t>
             </a:fld>
             <a:endParaRPr lang="fr-FR" sz="1200" b="0" u="none" strike="noStrike">
               <a:solidFill>
@@ -9936,7 +9936,7 @@
                 <a:uFillTx/>
                 <a:latin typeface="Calibri"/>
               </a:rPr>
-              <a:t> </a:t>
+              <a:t>&lt;date/heure&gt;</a:t>
             </a:r>
             <a:endParaRPr lang="fr-FR" sz="1200" b="0" u="none" strike="noStrike">
               <a:solidFill>
@@ -10002,7 +10002,7 @@
                 <a:uFillTx/>
                 <a:latin typeface="Times New Roman"/>
               </a:rPr>
-              <a:t> </a:t>
+              <a:t>&lt;pied de page&gt;</a:t>
             </a:r>
             <a:endParaRPr lang="fr-FR" sz="1400" b="0" u="none" strike="noStrike">
               <a:solidFill>
@@ -10067,7 +10067,7 @@
               </a:lnSpc>
               <a:buNone/>
             </a:pPr>
-            <a:fld id="{BAC7E159-D377-45FF-B96F-30CA04063344}" type="slidenum">
+            <a:fld id="{1E715D17-162B-4957-83B8-DDC9184FEB29}" type="slidenum">
               <a:rPr lang="en-US" sz="1200" b="0" u="none" strike="noStrike">
                 <a:solidFill>
                   <a:schemeClr val="dk1">
@@ -10078,7 +10078,7 @@
                 <a:uFillTx/>
                 <a:latin typeface="Calibri"/>
               </a:rPr>
-              <a:t>1</a:t>
+              <a:t>&lt;numéro&gt;</a:t>
             </a:fld>
             <a:endParaRPr lang="fr-FR" sz="1200" b="0" u="none" strike="noStrike">
               <a:solidFill>

</xml_diff>